<commit_message>
Ahora da aviso de hacer pedido por si el cliente se olvido de hacer un pedido en el primer avis de las 9 ahora da aviso a las 15
</commit_message>
<xml_diff>
--- a/TuStockApp_Presentacion.pptx
+++ b/TuStockApp_Presentacion.pptx
@@ -2684,7 +2684,7 @@
                 <a:ea typeface="Calibri" pitchFamily="34" charset="-122"/>
                 <a:cs typeface="Calibri" pitchFamily="34" charset="-120"/>
               </a:rPr>
-              <a:t>Si un cliente activó las notificaciones y todavía no hizo su pedido en el día, TuStockApp le manda un aviso al celular para que no se olvide.</a:t>
+              <a:t>Si un cliente activó las notificaciones y todavía no hizo su pedido en el día, TuStockApp le manda un aviso al celular a las 9:00 — y si a las 15:30 todavía no pidió nada, le llega un segundo aviso.</a:t>
             </a:r>
             <a:endParaRPr lang="en-US" sz="2200" dirty="0"/>
           </a:p>
@@ -2723,7 +2723,7 @@
                 <a:ea typeface="Calibri" pitchFamily="34" charset="-122"/>
                 <a:cs typeface="Calibri" pitchFamily="34" charset="-120"/>
               </a:rPr>
-              <a:t>Es automático, todos los días — como si vos mismo lo estuvieras llamando.</a:t>
+              <a:t>Es automático, hasta dos veces por día si hace falta — como si vos mismo lo estuvieras llamando.</a:t>
             </a:r>
             <a:endParaRPr lang="en-US" sz="1600" dirty="0"/>
           </a:p>
@@ -2806,7 +2806,7 @@
                 <a:ea typeface="Cambria" pitchFamily="34" charset="-122"/>
                 <a:cs typeface="Cambria" pitchFamily="34" charset="-120"/>
               </a:rPr>
-              <a:t>9:00 am</a:t>
+              <a:t>9:00 y 15:30</a:t>
             </a:r>
             <a:endParaRPr lang="en-US" sz="2400" dirty="0"/>
           </a:p>
@@ -2845,7 +2845,7 @@
                 <a:ea typeface="Calibri" pitchFamily="34" charset="-122"/>
                 <a:cs typeface="Calibri" pitchFamily="34" charset="-120"/>
               </a:rPr>
-              <a:t>todos los días, hora Uruguay</a:t>
+              <a:t>avisos posibles, hora Uruguay</a:t>
             </a:r>
             <a:endParaRPr lang="en-US" sz="1300" dirty="0"/>
           </a:p>
@@ -7796,7 +7796,7 @@
                 <a:ea typeface="Calibri" pitchFamily="34" charset="-122"/>
                 <a:cs typeface="Calibri" pitchFamily="34" charset="-120"/>
               </a:rPr>
-              <a:t>Recordatorio diario 9am</a:t>
+              <a:t>Recordatorio diario (2x)</a:t>
             </a:r>
             <a:endParaRPr lang="en-US" sz="1400" dirty="0"/>
           </a:p>

</xml_diff>